<commit_message>
marka etiketleme düzeltmesi: marka slug BAŞINDA eşleşir (renk/son-token false-positive giderildi)
- extractBrand: önce slug başında eşleşme; içerde eşleşmede renk-marka tokenları (mavi) hariç
  ve SON token konumundaki eşleşme reddedilir (renk/varyant). Böylece
  "xiaomi-powerbank-...-mavi" → Mavi DEĞİL Xiaomi; "mavi-erkek-pantolon" → Mavi (korunur);
  "united-colors-of-benetton-..." → Benetton (korunur).
- BRAND_TOKENS genişletildi (Xiaomi, Samsung, Sony, JBL, Globber, Maisto, Crocs, Vans, Levi's vb.)
- ~303 hatalı renk-etiketi temizlendi; Mavi 1299→1175, Adidas (1229) Mavi'yi geçti, marka sayısı 166
- data/ai-data.js rebuild; sunum deck + PPTX (görsel + editable) marka rakamları güncellendi & yeniden render

Co-Authored-By: Claude Opus 4.8 <noreply@anthropic.com>
</commit_message>
<xml_diff>
--- a/sunum/Ozdilekteyim-AI-Trafik-Analizi-Sunum-editable.pptx
+++ b/sunum/Ozdilekteyim-AI-Trafik-Analizi-Sunum-editable.pptx
@@ -1104,10 +1104,10 @@
                     <c:v>Özdilek</c:v>
                   </c:pt>
                   <c:pt idx="1">
-                    <c:v>Mavi</c:v>
+                    <c:v>Adidas</c:v>
                   </c:pt>
                   <c:pt idx="2">
-                    <c:v>Adidas</c:v>
+                    <c:v>Mavi</c:v>
                   </c:pt>
                   <c:pt idx="3">
                     <c:v>Skechers</c:v>
@@ -1141,31 +1141,31 @@
                 <c:formatCode>General</c:formatCode>
                 <c:ptCount val="10"/>
                 <c:pt idx="0">
-                  <c:v>1823</c:v>
+                  <c:v>1818</c:v>
                 </c:pt>
                 <c:pt idx="1">
-                  <c:v>1299</c:v>
+                  <c:v>1229</c:v>
                 </c:pt>
                 <c:pt idx="2">
-                  <c:v>1232</c:v>
+                  <c:v>1175</c:v>
                 </c:pt>
                 <c:pt idx="3">
-                  <c:v>867</c:v>
+                  <c:v>864</c:v>
                 </c:pt>
                 <c:pt idx="4">
-                  <c:v>847</c:v>
+                  <c:v>846</c:v>
                 </c:pt>
                 <c:pt idx="5">
                   <c:v>610</c:v>
                 </c:pt>
                 <c:pt idx="6">
-                  <c:v>588</c:v>
+                  <c:v>585</c:v>
                 </c:pt>
                 <c:pt idx="7">
-                  <c:v>542</c:v>
+                  <c:v>536</c:v>
                 </c:pt>
                 <c:pt idx="8">
-                  <c:v>472</c:v>
+                  <c:v>471</c:v>
                 </c:pt>
                 <c:pt idx="9">
                   <c:v>454</c:v>
@@ -1393,13 +1393,13 @@
                     <c:v>Puma</c:v>
                   </c:pt>
                   <c:pt idx="7">
+                    <c:v>Urban Care</c:v>
+                  </c:pt>
+                  <c:pt idx="8">
                     <c:v>Mavi</c:v>
                   </c:pt>
-                  <c:pt idx="8">
-                    <c:v>Urban Care</c:v>
-                  </c:pt>
                   <c:pt idx="9">
-                    <c:v>Under Armour</c:v>
+                    <c:v>Crocs</c:v>
                   </c:pt>
                 </c:lvl>
               </c:multiLvlStrCache>
@@ -1412,34 +1412,34 @@
                 <c:formatCode>General</c:formatCode>
                 <c:ptCount val="10"/>
                 <c:pt idx="0">
-                  <c:v>391</c:v>
+                  <c:v>388</c:v>
                 </c:pt>
                 <c:pt idx="1">
-                  <c:v>300</c:v>
+                  <c:v>299</c:v>
                 </c:pt>
                 <c:pt idx="2">
-                  <c:v>277</c:v>
+                  <c:v>274</c:v>
                 </c:pt>
                 <c:pt idx="3">
                   <c:v>247</c:v>
                 </c:pt>
                 <c:pt idx="4">
-                  <c:v>247</c:v>
+                  <c:v>246</c:v>
                 </c:pt>
                 <c:pt idx="5">
-                  <c:v>190</c:v>
+                  <c:v>189</c:v>
                 </c:pt>
                 <c:pt idx="6">
-                  <c:v>140</c:v>
+                  <c:v>138</c:v>
                 </c:pt>
                 <c:pt idx="7">
-                  <c:v>123</c:v>
+                  <c:v>87</c:v>
                 </c:pt>
                 <c:pt idx="8">
-                  <c:v>89</c:v>
+                  <c:v>85</c:v>
                 </c:pt>
                 <c:pt idx="9">
-                  <c:v>69</c:v>
+                  <c:v>81</c:v>
                 </c:pt>
               </c:numCache>
             </c:numRef>
@@ -22726,7 +22726,7 @@
                           <a:ea typeface="Calibri" pitchFamily="34" charset="-122"/>
                           <a:cs typeface="Calibri" pitchFamily="34" charset="-120"/>
                         </a:rPr>
-                        <a:t>1.823</a:t>
+                        <a:t>1.818</a:t>
                       </a:r>
                       <a:endParaRPr lang="en-US" sz="1050" dirty="0">
                         <a:latin typeface="Calibri" charset="0"/>
@@ -22857,6 +22857,268 @@
                           <a:cs typeface="Calibri" pitchFamily="34" charset="-120"/>
                         </a:rPr>
                         <a:t>12</a:t>
+                      </a:r>
+                      <a:endParaRPr lang="en-US" sz="1050" dirty="0">
+                        <a:latin typeface="Calibri" charset="0"/>
+                        <a:ea typeface="Calibri" charset="0"/>
+                        <a:cs typeface="Calibri" charset="0"/>
+                      </a:endParaRPr>
+                    </a:p>
+                  </a:txBody>
+                  <a:tcPr marL="91440" marR="91440" marT="45720" marB="45720" anchor="ctr">
+                    <a:lnL w="6350" cap="flat" cmpd="sng" algn="ctr">
+                      <a:solidFill>
+                        <a:srgbClr val="E0E0E0"/>
+                      </a:solidFill>
+                      <a:prstDash val="solid"/>
+                      <a:round/>
+                      <a:headEnd type="none" w="med" len="med"/>
+                      <a:tailEnd type="none" w="med" len="med"/>
+                    </a:lnL>
+                    <a:lnR w="6350" cap="flat" cmpd="sng" algn="ctr">
+                      <a:solidFill>
+                        <a:srgbClr val="E0E0E0"/>
+                      </a:solidFill>
+                      <a:prstDash val="solid"/>
+                      <a:round/>
+                      <a:headEnd type="none" w="med" len="med"/>
+                      <a:tailEnd type="none" w="med" len="med"/>
+                    </a:lnR>
+                    <a:lnT w="6350" cap="flat" cmpd="sng" algn="ctr">
+                      <a:solidFill>
+                        <a:srgbClr val="E0E0E0"/>
+                      </a:solidFill>
+                      <a:prstDash val="solid"/>
+                      <a:round/>
+                      <a:headEnd type="none" w="med" len="med"/>
+                      <a:tailEnd type="none" w="med" len="med"/>
+                    </a:lnT>
+                    <a:lnB w="6350" cap="flat" cmpd="sng" algn="ctr">
+                      <a:solidFill>
+                        <a:srgbClr val="E0E0E0"/>
+                      </a:solidFill>
+                      <a:prstDash val="solid"/>
+                      <a:round/>
+                      <a:headEnd type="none" w="med" len="med"/>
+                      <a:tailEnd type="none" w="med" len="med"/>
+                    </a:lnB>
+                  </a:tcPr>
+                </a:tc>
+              </a:tr>
+              <a:tr h="329184">
+                <a:tc>
+                  <a:txBody>
+                    <a:bodyPr/>
+                    <a:lstStyle/>
+                    <a:p>
+                      <a:pPr indent="0" marL="0">
+                        <a:buNone/>
+                      </a:pPr>
+                      <a:r>
+                        <a:rPr lang="en-US" sz="1050" dirty="0">
+                          <a:solidFill>
+                            <a:srgbClr val="10332F"/>
+                          </a:solidFill>
+                          <a:latin typeface="Calibri" pitchFamily="34" charset="0"/>
+                          <a:ea typeface="Calibri" pitchFamily="34" charset="-122"/>
+                          <a:cs typeface="Calibri" pitchFamily="34" charset="-120"/>
+                        </a:rPr>
+                        <a:t>Adidas</a:t>
+                      </a:r>
+                      <a:endParaRPr lang="en-US" sz="1050" dirty="0">
+                        <a:latin typeface="Calibri" charset="0"/>
+                        <a:ea typeface="Calibri" charset="0"/>
+                        <a:cs typeface="Calibri" charset="0"/>
+                      </a:endParaRPr>
+                    </a:p>
+                  </a:txBody>
+                  <a:tcPr marL="91440" marR="91440" marT="45720" marB="45720" anchor="ctr">
+                    <a:lnL w="6350" cap="flat" cmpd="sng" algn="ctr">
+                      <a:solidFill>
+                        <a:srgbClr val="E0E0E0"/>
+                      </a:solidFill>
+                      <a:prstDash val="solid"/>
+                      <a:round/>
+                      <a:headEnd type="none" w="med" len="med"/>
+                      <a:tailEnd type="none" w="med" len="med"/>
+                    </a:lnL>
+                    <a:lnR w="6350" cap="flat" cmpd="sng" algn="ctr">
+                      <a:solidFill>
+                        <a:srgbClr val="E0E0E0"/>
+                      </a:solidFill>
+                      <a:prstDash val="solid"/>
+                      <a:round/>
+                      <a:headEnd type="none" w="med" len="med"/>
+                      <a:tailEnd type="none" w="med" len="med"/>
+                    </a:lnR>
+                    <a:lnT w="6350" cap="flat" cmpd="sng" algn="ctr">
+                      <a:solidFill>
+                        <a:srgbClr val="E0E0E0"/>
+                      </a:solidFill>
+                      <a:prstDash val="solid"/>
+                      <a:round/>
+                      <a:headEnd type="none" w="med" len="med"/>
+                      <a:tailEnd type="none" w="med" len="med"/>
+                    </a:lnT>
+                    <a:lnB w="6350" cap="flat" cmpd="sng" algn="ctr">
+                      <a:solidFill>
+                        <a:srgbClr val="E0E0E0"/>
+                      </a:solidFill>
+                      <a:prstDash val="solid"/>
+                      <a:round/>
+                      <a:headEnd type="none" w="med" len="med"/>
+                      <a:tailEnd type="none" w="med" len="med"/>
+                    </a:lnB>
+                  </a:tcPr>
+                </a:tc>
+                <a:tc>
+                  <a:txBody>
+                    <a:bodyPr/>
+                    <a:lstStyle/>
+                    <a:p>
+                      <a:pPr algn="r" indent="0" marL="0">
+                        <a:buNone/>
+                      </a:pPr>
+                      <a:r>
+                        <a:rPr lang="en-US" sz="1050" dirty="0">
+                          <a:solidFill>
+                            <a:srgbClr val="10332F"/>
+                          </a:solidFill>
+                          <a:latin typeface="Calibri" pitchFamily="34" charset="0"/>
+                          <a:ea typeface="Calibri" pitchFamily="34" charset="-122"/>
+                          <a:cs typeface="Calibri" pitchFamily="34" charset="-120"/>
+                        </a:rPr>
+                        <a:t>1.229</a:t>
+                      </a:r>
+                      <a:endParaRPr lang="en-US" sz="1050" dirty="0">
+                        <a:latin typeface="Calibri" charset="0"/>
+                        <a:ea typeface="Calibri" charset="0"/>
+                        <a:cs typeface="Calibri" charset="0"/>
+                      </a:endParaRPr>
+                    </a:p>
+                  </a:txBody>
+                  <a:tcPr marL="91440" marR="91440" marT="45720" marB="45720" anchor="ctr">
+                    <a:lnL w="6350" cap="flat" cmpd="sng" algn="ctr">
+                      <a:solidFill>
+                        <a:srgbClr val="E0E0E0"/>
+                      </a:solidFill>
+                      <a:prstDash val="solid"/>
+                      <a:round/>
+                      <a:headEnd type="none" w="med" len="med"/>
+                      <a:tailEnd type="none" w="med" len="med"/>
+                    </a:lnL>
+                    <a:lnR w="6350" cap="flat" cmpd="sng" algn="ctr">
+                      <a:solidFill>
+                        <a:srgbClr val="E0E0E0"/>
+                      </a:solidFill>
+                      <a:prstDash val="solid"/>
+                      <a:round/>
+                      <a:headEnd type="none" w="med" len="med"/>
+                      <a:tailEnd type="none" w="med" len="med"/>
+                    </a:lnR>
+                    <a:lnT w="6350" cap="flat" cmpd="sng" algn="ctr">
+                      <a:solidFill>
+                        <a:srgbClr val="E0E0E0"/>
+                      </a:solidFill>
+                      <a:prstDash val="solid"/>
+                      <a:round/>
+                      <a:headEnd type="none" w="med" len="med"/>
+                      <a:tailEnd type="none" w="med" len="med"/>
+                    </a:lnT>
+                    <a:lnB w="6350" cap="flat" cmpd="sng" algn="ctr">
+                      <a:solidFill>
+                        <a:srgbClr val="E0E0E0"/>
+                      </a:solidFill>
+                      <a:prstDash val="solid"/>
+                      <a:round/>
+                      <a:headEnd type="none" w="med" len="med"/>
+                      <a:tailEnd type="none" w="med" len="med"/>
+                    </a:lnB>
+                  </a:tcPr>
+                </a:tc>
+                <a:tc>
+                  <a:txBody>
+                    <a:bodyPr/>
+                    <a:lstStyle/>
+                    <a:p>
+                      <a:pPr algn="r" indent="0" marL="0">
+                        <a:buNone/>
+                      </a:pPr>
+                      <a:r>
+                        <a:rPr lang="en-US" sz="1050" dirty="0">
+                          <a:solidFill>
+                            <a:srgbClr val="10332F"/>
+                          </a:solidFill>
+                          <a:latin typeface="Calibri" pitchFamily="34" charset="0"/>
+                          <a:ea typeface="Calibri" pitchFamily="34" charset="-122"/>
+                          <a:cs typeface="Calibri" pitchFamily="34" charset="-120"/>
+                        </a:rPr>
+                        <a:t>₺34,5K</a:t>
+                      </a:r>
+                      <a:endParaRPr lang="en-US" sz="1050" dirty="0">
+                        <a:latin typeface="Calibri" charset="0"/>
+                        <a:ea typeface="Calibri" charset="0"/>
+                        <a:cs typeface="Calibri" charset="0"/>
+                      </a:endParaRPr>
+                    </a:p>
+                  </a:txBody>
+                  <a:tcPr marL="91440" marR="91440" marT="45720" marB="45720" anchor="ctr">
+                    <a:lnL w="6350" cap="flat" cmpd="sng" algn="ctr">
+                      <a:solidFill>
+                        <a:srgbClr val="E0E0E0"/>
+                      </a:solidFill>
+                      <a:prstDash val="solid"/>
+                      <a:round/>
+                      <a:headEnd type="none" w="med" len="med"/>
+                      <a:tailEnd type="none" w="med" len="med"/>
+                    </a:lnL>
+                    <a:lnR w="6350" cap="flat" cmpd="sng" algn="ctr">
+                      <a:solidFill>
+                        <a:srgbClr val="E0E0E0"/>
+                      </a:solidFill>
+                      <a:prstDash val="solid"/>
+                      <a:round/>
+                      <a:headEnd type="none" w="med" len="med"/>
+                      <a:tailEnd type="none" w="med" len="med"/>
+                    </a:lnR>
+                    <a:lnT w="6350" cap="flat" cmpd="sng" algn="ctr">
+                      <a:solidFill>
+                        <a:srgbClr val="E0E0E0"/>
+                      </a:solidFill>
+                      <a:prstDash val="solid"/>
+                      <a:round/>
+                      <a:headEnd type="none" w="med" len="med"/>
+                      <a:tailEnd type="none" w="med" len="med"/>
+                    </a:lnT>
+                    <a:lnB w="6350" cap="flat" cmpd="sng" algn="ctr">
+                      <a:solidFill>
+                        <a:srgbClr val="E0E0E0"/>
+                      </a:solidFill>
+                      <a:prstDash val="solid"/>
+                      <a:round/>
+                      <a:headEnd type="none" w="med" len="med"/>
+                      <a:tailEnd type="none" w="med" len="med"/>
+                    </a:lnB>
+                  </a:tcPr>
+                </a:tc>
+                <a:tc>
+                  <a:txBody>
+                    <a:bodyPr/>
+                    <a:lstStyle/>
+                    <a:p>
+                      <a:pPr algn="r" indent="0" marL="0">
+                        <a:buNone/>
+                      </a:pPr>
+                      <a:r>
+                        <a:rPr lang="en-US" sz="1050" dirty="0">
+                          <a:solidFill>
+                            <a:srgbClr val="10332F"/>
+                          </a:solidFill>
+                          <a:latin typeface="Calibri" pitchFamily="34" charset="0"/>
+                          <a:ea typeface="Calibri" pitchFamily="34" charset="-122"/>
+                          <a:cs typeface="Calibri" pitchFamily="34" charset="-120"/>
+                        </a:rPr>
+                        <a:t>13</a:t>
                       </a:r>
                       <a:endParaRPr lang="en-US" sz="1050" dirty="0">
                         <a:latin typeface="Calibri" charset="0"/>
@@ -22988,7 +23250,7 @@
                           <a:ea typeface="Calibri" pitchFamily="34" charset="-122"/>
                           <a:cs typeface="Calibri" pitchFamily="34" charset="-120"/>
                         </a:rPr>
-                        <a:t>1.299</a:t>
+                        <a:t>1.175</a:t>
                       </a:r>
                       <a:endParaRPr lang="en-US" sz="1050" dirty="0">
                         <a:latin typeface="Calibri" charset="0"/>
@@ -23119,268 +23381,6 @@
                           <a:cs typeface="Calibri" pitchFamily="34" charset="-120"/>
                         </a:rPr>
                         <a:t>11</a:t>
-                      </a:r>
-                      <a:endParaRPr lang="en-US" sz="1050" dirty="0">
-                        <a:latin typeface="Calibri" charset="0"/>
-                        <a:ea typeface="Calibri" charset="0"/>
-                        <a:cs typeface="Calibri" charset="0"/>
-                      </a:endParaRPr>
-                    </a:p>
-                  </a:txBody>
-                  <a:tcPr marL="91440" marR="91440" marT="45720" marB="45720" anchor="ctr">
-                    <a:lnL w="6350" cap="flat" cmpd="sng" algn="ctr">
-                      <a:solidFill>
-                        <a:srgbClr val="E0E0E0"/>
-                      </a:solidFill>
-                      <a:prstDash val="solid"/>
-                      <a:round/>
-                      <a:headEnd type="none" w="med" len="med"/>
-                      <a:tailEnd type="none" w="med" len="med"/>
-                    </a:lnL>
-                    <a:lnR w="6350" cap="flat" cmpd="sng" algn="ctr">
-                      <a:solidFill>
-                        <a:srgbClr val="E0E0E0"/>
-                      </a:solidFill>
-                      <a:prstDash val="solid"/>
-                      <a:round/>
-                      <a:headEnd type="none" w="med" len="med"/>
-                      <a:tailEnd type="none" w="med" len="med"/>
-                    </a:lnR>
-                    <a:lnT w="6350" cap="flat" cmpd="sng" algn="ctr">
-                      <a:solidFill>
-                        <a:srgbClr val="E0E0E0"/>
-                      </a:solidFill>
-                      <a:prstDash val="solid"/>
-                      <a:round/>
-                      <a:headEnd type="none" w="med" len="med"/>
-                      <a:tailEnd type="none" w="med" len="med"/>
-                    </a:lnT>
-                    <a:lnB w="6350" cap="flat" cmpd="sng" algn="ctr">
-                      <a:solidFill>
-                        <a:srgbClr val="E0E0E0"/>
-                      </a:solidFill>
-                      <a:prstDash val="solid"/>
-                      <a:round/>
-                      <a:headEnd type="none" w="med" len="med"/>
-                      <a:tailEnd type="none" w="med" len="med"/>
-                    </a:lnB>
-                  </a:tcPr>
-                </a:tc>
-              </a:tr>
-              <a:tr h="329184">
-                <a:tc>
-                  <a:txBody>
-                    <a:bodyPr/>
-                    <a:lstStyle/>
-                    <a:p>
-                      <a:pPr indent="0" marL="0">
-                        <a:buNone/>
-                      </a:pPr>
-                      <a:r>
-                        <a:rPr lang="en-US" sz="1050" dirty="0">
-                          <a:solidFill>
-                            <a:srgbClr val="10332F"/>
-                          </a:solidFill>
-                          <a:latin typeface="Calibri" pitchFamily="34" charset="0"/>
-                          <a:ea typeface="Calibri" pitchFamily="34" charset="-122"/>
-                          <a:cs typeface="Calibri" pitchFamily="34" charset="-120"/>
-                        </a:rPr>
-                        <a:t>Adidas</a:t>
-                      </a:r>
-                      <a:endParaRPr lang="en-US" sz="1050" dirty="0">
-                        <a:latin typeface="Calibri" charset="0"/>
-                        <a:ea typeface="Calibri" charset="0"/>
-                        <a:cs typeface="Calibri" charset="0"/>
-                      </a:endParaRPr>
-                    </a:p>
-                  </a:txBody>
-                  <a:tcPr marL="91440" marR="91440" marT="45720" marB="45720" anchor="ctr">
-                    <a:lnL w="6350" cap="flat" cmpd="sng" algn="ctr">
-                      <a:solidFill>
-                        <a:srgbClr val="E0E0E0"/>
-                      </a:solidFill>
-                      <a:prstDash val="solid"/>
-                      <a:round/>
-                      <a:headEnd type="none" w="med" len="med"/>
-                      <a:tailEnd type="none" w="med" len="med"/>
-                    </a:lnL>
-                    <a:lnR w="6350" cap="flat" cmpd="sng" algn="ctr">
-                      <a:solidFill>
-                        <a:srgbClr val="E0E0E0"/>
-                      </a:solidFill>
-                      <a:prstDash val="solid"/>
-                      <a:round/>
-                      <a:headEnd type="none" w="med" len="med"/>
-                      <a:tailEnd type="none" w="med" len="med"/>
-                    </a:lnR>
-                    <a:lnT w="6350" cap="flat" cmpd="sng" algn="ctr">
-                      <a:solidFill>
-                        <a:srgbClr val="E0E0E0"/>
-                      </a:solidFill>
-                      <a:prstDash val="solid"/>
-                      <a:round/>
-                      <a:headEnd type="none" w="med" len="med"/>
-                      <a:tailEnd type="none" w="med" len="med"/>
-                    </a:lnT>
-                    <a:lnB w="6350" cap="flat" cmpd="sng" algn="ctr">
-                      <a:solidFill>
-                        <a:srgbClr val="E0E0E0"/>
-                      </a:solidFill>
-                      <a:prstDash val="solid"/>
-                      <a:round/>
-                      <a:headEnd type="none" w="med" len="med"/>
-                      <a:tailEnd type="none" w="med" len="med"/>
-                    </a:lnB>
-                  </a:tcPr>
-                </a:tc>
-                <a:tc>
-                  <a:txBody>
-                    <a:bodyPr/>
-                    <a:lstStyle/>
-                    <a:p>
-                      <a:pPr algn="r" indent="0" marL="0">
-                        <a:buNone/>
-                      </a:pPr>
-                      <a:r>
-                        <a:rPr lang="en-US" sz="1050" dirty="0">
-                          <a:solidFill>
-                            <a:srgbClr val="10332F"/>
-                          </a:solidFill>
-                          <a:latin typeface="Calibri" pitchFamily="34" charset="0"/>
-                          <a:ea typeface="Calibri" pitchFamily="34" charset="-122"/>
-                          <a:cs typeface="Calibri" pitchFamily="34" charset="-120"/>
-                        </a:rPr>
-                        <a:t>1.232</a:t>
-                      </a:r>
-                      <a:endParaRPr lang="en-US" sz="1050" dirty="0">
-                        <a:latin typeface="Calibri" charset="0"/>
-                        <a:ea typeface="Calibri" charset="0"/>
-                        <a:cs typeface="Calibri" charset="0"/>
-                      </a:endParaRPr>
-                    </a:p>
-                  </a:txBody>
-                  <a:tcPr marL="91440" marR="91440" marT="45720" marB="45720" anchor="ctr">
-                    <a:lnL w="6350" cap="flat" cmpd="sng" algn="ctr">
-                      <a:solidFill>
-                        <a:srgbClr val="E0E0E0"/>
-                      </a:solidFill>
-                      <a:prstDash val="solid"/>
-                      <a:round/>
-                      <a:headEnd type="none" w="med" len="med"/>
-                      <a:tailEnd type="none" w="med" len="med"/>
-                    </a:lnL>
-                    <a:lnR w="6350" cap="flat" cmpd="sng" algn="ctr">
-                      <a:solidFill>
-                        <a:srgbClr val="E0E0E0"/>
-                      </a:solidFill>
-                      <a:prstDash val="solid"/>
-                      <a:round/>
-                      <a:headEnd type="none" w="med" len="med"/>
-                      <a:tailEnd type="none" w="med" len="med"/>
-                    </a:lnR>
-                    <a:lnT w="6350" cap="flat" cmpd="sng" algn="ctr">
-                      <a:solidFill>
-                        <a:srgbClr val="E0E0E0"/>
-                      </a:solidFill>
-                      <a:prstDash val="solid"/>
-                      <a:round/>
-                      <a:headEnd type="none" w="med" len="med"/>
-                      <a:tailEnd type="none" w="med" len="med"/>
-                    </a:lnT>
-                    <a:lnB w="6350" cap="flat" cmpd="sng" algn="ctr">
-                      <a:solidFill>
-                        <a:srgbClr val="E0E0E0"/>
-                      </a:solidFill>
-                      <a:prstDash val="solid"/>
-                      <a:round/>
-                      <a:headEnd type="none" w="med" len="med"/>
-                      <a:tailEnd type="none" w="med" len="med"/>
-                    </a:lnB>
-                  </a:tcPr>
-                </a:tc>
-                <a:tc>
-                  <a:txBody>
-                    <a:bodyPr/>
-                    <a:lstStyle/>
-                    <a:p>
-                      <a:pPr algn="r" indent="0" marL="0">
-                        <a:buNone/>
-                      </a:pPr>
-                      <a:r>
-                        <a:rPr lang="en-US" sz="1050" dirty="0">
-                          <a:solidFill>
-                            <a:srgbClr val="10332F"/>
-                          </a:solidFill>
-                          <a:latin typeface="Calibri" pitchFamily="34" charset="0"/>
-                          <a:ea typeface="Calibri" pitchFamily="34" charset="-122"/>
-                          <a:cs typeface="Calibri" pitchFamily="34" charset="-120"/>
-                        </a:rPr>
-                        <a:t>₺34,5K</a:t>
-                      </a:r>
-                      <a:endParaRPr lang="en-US" sz="1050" dirty="0">
-                        <a:latin typeface="Calibri" charset="0"/>
-                        <a:ea typeface="Calibri" charset="0"/>
-                        <a:cs typeface="Calibri" charset="0"/>
-                      </a:endParaRPr>
-                    </a:p>
-                  </a:txBody>
-                  <a:tcPr marL="91440" marR="91440" marT="45720" marB="45720" anchor="ctr">
-                    <a:lnL w="6350" cap="flat" cmpd="sng" algn="ctr">
-                      <a:solidFill>
-                        <a:srgbClr val="E0E0E0"/>
-                      </a:solidFill>
-                      <a:prstDash val="solid"/>
-                      <a:round/>
-                      <a:headEnd type="none" w="med" len="med"/>
-                      <a:tailEnd type="none" w="med" len="med"/>
-                    </a:lnL>
-                    <a:lnR w="6350" cap="flat" cmpd="sng" algn="ctr">
-                      <a:solidFill>
-                        <a:srgbClr val="E0E0E0"/>
-                      </a:solidFill>
-                      <a:prstDash val="solid"/>
-                      <a:round/>
-                      <a:headEnd type="none" w="med" len="med"/>
-                      <a:tailEnd type="none" w="med" len="med"/>
-                    </a:lnR>
-                    <a:lnT w="6350" cap="flat" cmpd="sng" algn="ctr">
-                      <a:solidFill>
-                        <a:srgbClr val="E0E0E0"/>
-                      </a:solidFill>
-                      <a:prstDash val="solid"/>
-                      <a:round/>
-                      <a:headEnd type="none" w="med" len="med"/>
-                      <a:tailEnd type="none" w="med" len="med"/>
-                    </a:lnT>
-                    <a:lnB w="6350" cap="flat" cmpd="sng" algn="ctr">
-                      <a:solidFill>
-                        <a:srgbClr val="E0E0E0"/>
-                      </a:solidFill>
-                      <a:prstDash val="solid"/>
-                      <a:round/>
-                      <a:headEnd type="none" w="med" len="med"/>
-                      <a:tailEnd type="none" w="med" len="med"/>
-                    </a:lnB>
-                  </a:tcPr>
-                </a:tc>
-                <a:tc>
-                  <a:txBody>
-                    <a:bodyPr/>
-                    <a:lstStyle/>
-                    <a:p>
-                      <a:pPr algn="r" indent="0" marL="0">
-                        <a:buNone/>
-                      </a:pPr>
-                      <a:r>
-                        <a:rPr lang="en-US" sz="1050" dirty="0">
-                          <a:solidFill>
-                            <a:srgbClr val="10332F"/>
-                          </a:solidFill>
-                          <a:latin typeface="Calibri" pitchFamily="34" charset="0"/>
-                          <a:ea typeface="Calibri" pitchFamily="34" charset="-122"/>
-                          <a:cs typeface="Calibri" pitchFamily="34" charset="-120"/>
-                        </a:rPr>
-                        <a:t>13</a:t>
                       </a:r>
                       <a:endParaRPr lang="en-US" sz="1050" dirty="0">
                         <a:latin typeface="Calibri" charset="0"/>
@@ -23512,7 +23512,7 @@
                           <a:ea typeface="Calibri" pitchFamily="34" charset="-122"/>
                           <a:cs typeface="Calibri" pitchFamily="34" charset="-120"/>
                         </a:rPr>
-                        <a:t>867</a:t>
+                        <a:t>864</a:t>
                       </a:r>
                       <a:endParaRPr lang="en-US" sz="1050" dirty="0">
                         <a:latin typeface="Calibri" charset="0"/>
@@ -23774,7 +23774,7 @@
                           <a:ea typeface="Calibri" pitchFamily="34" charset="-122"/>
                           <a:cs typeface="Calibri" pitchFamily="34" charset="-120"/>
                         </a:rPr>
-                        <a:t>847</a:t>
+                        <a:t>846</a:t>
                       </a:r>
                       <a:endParaRPr lang="en-US" sz="1050" dirty="0">
                         <a:latin typeface="Calibri" charset="0"/>
@@ -24298,7 +24298,7 @@
                           <a:ea typeface="Calibri" pitchFamily="34" charset="-122"/>
                           <a:cs typeface="Calibri" pitchFamily="34" charset="-120"/>
                         </a:rPr>
-                        <a:t>588</a:t>
+                        <a:t>585</a:t>
                       </a:r>
                       <a:endParaRPr lang="en-US" sz="1050" dirty="0">
                         <a:latin typeface="Calibri" charset="0"/>
@@ -24560,7 +24560,7 @@
                           <a:ea typeface="Calibri" pitchFamily="34" charset="-122"/>
                           <a:cs typeface="Calibri" pitchFamily="34" charset="-120"/>
                         </a:rPr>
-                        <a:t>542</a:t>
+                        <a:t>536</a:t>
                       </a:r>
                       <a:endParaRPr lang="en-US" sz="1050" dirty="0">
                         <a:latin typeface="Calibri" charset="0"/>
@@ -24822,7 +24822,7 @@
                           <a:ea typeface="Calibri" pitchFamily="34" charset="-122"/>
                           <a:cs typeface="Calibri" pitchFamily="34" charset="-120"/>
                         </a:rPr>
-                        <a:t>472</a:t>
+                        <a:t>471</a:t>
                       </a:r>
                       <a:endParaRPr lang="en-US" sz="1050" dirty="0">
                         <a:latin typeface="Calibri" charset="0"/>

</xml_diff>